<commit_message>
Make README and visual deck Chinese-first
</commit_message>
<xml_diff>
--- a/docs/MAGG_visual_deck.pptx
+++ b/docs/MAGG_visual_deck.pptx
@@ -2,7 +2,7 @@
 <file path=ppt/presentation.xml><?xml version="1.0" encoding="utf-8"?>
 <p:presentation xmlns:a="http://schemas.openxmlformats.org/drawingml/2006/main" xmlns:r="http://schemas.openxmlformats.org/officeDocument/2006/relationships" xmlns:p="http://schemas.openxmlformats.org/presentationml/2006/main">
   <p:sldMasterIdLst>
-    <p:sldMasterId id="2147483648" r:id="rId7"/>
+    <p:sldMasterId id="2147483648" r:id="rId13"/>
   </p:sldMasterIdLst>
   <p:sldIdLst>
     <p:sldId id="256" r:id="rId1"/>
@@ -11,6 +11,12 @@
     <p:sldId id="259" r:id="rId4"/>
     <p:sldId id="260" r:id="rId5"/>
     <p:sldId id="261" r:id="rId6"/>
+    <p:sldId id="262" r:id="rId7"/>
+    <p:sldId id="263" r:id="rId8"/>
+    <p:sldId id="264" r:id="rId9"/>
+    <p:sldId id="265" r:id="rId10"/>
+    <p:sldId id="266" r:id="rId11"/>
+    <p:sldId id="267" r:id="rId12"/>
   </p:sldIdLst>
   <p:sldSz cx="12192000" cy="6858000" type="wide"/>
   <p:notesSz cx="6858000" cy="9144000"/>
@@ -88,7 +94,154 @@
       </p:grpSpPr>
       <p:pic>
         <p:nvPicPr>
-          <p:cNvPr id="2" name="slide_01.png"/>
+          <p:cNvPr id="2" name="slide1.png"/>
+          <p:cNvPicPr>
+            <a:picLocks noChangeAspect="1"/>
+          </p:cNvPicPr>
+          <p:nvPr/>
+        </p:nvPicPr>
+        <p:blipFill>
+          <a:blip r:embed="rId1"/>
+          <a:stretch>
+            <a:fillRect/>
+          </a:stretch>
+        </p:blipFill>
+        <p:spPr>
+          <a:xfrm>
+            <a:off x="0" y="0"/>
+            <a:ext cx="12192000" cy="6858000"/>
+          </a:xfrm>
+          <a:prstGeom prst="rect">
+            <a:avLst/>
+          </a:prstGeom>
+        </p:spPr>
+      </p:pic>
+    </p:spTree>
+  </p:cSld>
+  <p:clrMapOvr>
+    <a:masterClrMapping/>
+  </p:clrMapOvr>
+</p:sld>
+</file>
+
+<file path=ppt/slides/slide10.xml><?xml version="1.0" encoding="utf-8"?>
+<p:sld xmlns:a="http://schemas.openxmlformats.org/drawingml/2006/main" xmlns:r="http://schemas.openxmlformats.org/officeDocument/2006/relationships" xmlns:p="http://schemas.openxmlformats.org/presentationml/2006/main">
+  <p:cSld>
+    <p:spTree>
+      <p:nvGrpSpPr>
+        <p:cNvPr id="1" name=""/>
+        <p:cNvGrpSpPr/>
+        <p:nvPr/>
+      </p:nvGrpSpPr>
+      <p:grpSpPr>
+        <a:xfrm>
+          <a:off x="0" y="0"/>
+          <a:ext cx="0" cy="0"/>
+          <a:chOff x="0" y="0"/>
+          <a:chExt cx="0" cy="0"/>
+        </a:xfrm>
+      </p:grpSpPr>
+      <p:pic>
+        <p:nvPicPr>
+          <p:cNvPr id="2" name="slide10.png"/>
+          <p:cNvPicPr>
+            <a:picLocks noChangeAspect="1"/>
+          </p:cNvPicPr>
+          <p:nvPr/>
+        </p:nvPicPr>
+        <p:blipFill>
+          <a:blip r:embed="rId1"/>
+          <a:stretch>
+            <a:fillRect/>
+          </a:stretch>
+        </p:blipFill>
+        <p:spPr>
+          <a:xfrm>
+            <a:off x="0" y="0"/>
+            <a:ext cx="12192000" cy="6858000"/>
+          </a:xfrm>
+          <a:prstGeom prst="rect">
+            <a:avLst/>
+          </a:prstGeom>
+        </p:spPr>
+      </p:pic>
+    </p:spTree>
+  </p:cSld>
+  <p:clrMapOvr>
+    <a:masterClrMapping/>
+  </p:clrMapOvr>
+</p:sld>
+</file>
+
+<file path=ppt/slides/slide11.xml><?xml version="1.0" encoding="utf-8"?>
+<p:sld xmlns:a="http://schemas.openxmlformats.org/drawingml/2006/main" xmlns:r="http://schemas.openxmlformats.org/officeDocument/2006/relationships" xmlns:p="http://schemas.openxmlformats.org/presentationml/2006/main">
+  <p:cSld>
+    <p:spTree>
+      <p:nvGrpSpPr>
+        <p:cNvPr id="1" name=""/>
+        <p:cNvGrpSpPr/>
+        <p:nvPr/>
+      </p:nvGrpSpPr>
+      <p:grpSpPr>
+        <a:xfrm>
+          <a:off x="0" y="0"/>
+          <a:ext cx="0" cy="0"/>
+          <a:chOff x="0" y="0"/>
+          <a:chExt cx="0" cy="0"/>
+        </a:xfrm>
+      </p:grpSpPr>
+      <p:pic>
+        <p:nvPicPr>
+          <p:cNvPr id="2" name="slide11.png"/>
+          <p:cNvPicPr>
+            <a:picLocks noChangeAspect="1"/>
+          </p:cNvPicPr>
+          <p:nvPr/>
+        </p:nvPicPr>
+        <p:blipFill>
+          <a:blip r:embed="rId1"/>
+          <a:stretch>
+            <a:fillRect/>
+          </a:stretch>
+        </p:blipFill>
+        <p:spPr>
+          <a:xfrm>
+            <a:off x="0" y="0"/>
+            <a:ext cx="12192000" cy="6858000"/>
+          </a:xfrm>
+          <a:prstGeom prst="rect">
+            <a:avLst/>
+          </a:prstGeom>
+        </p:spPr>
+      </p:pic>
+    </p:spTree>
+  </p:cSld>
+  <p:clrMapOvr>
+    <a:masterClrMapping/>
+  </p:clrMapOvr>
+</p:sld>
+</file>
+
+<file path=ppt/slides/slide12.xml><?xml version="1.0" encoding="utf-8"?>
+<p:sld xmlns:a="http://schemas.openxmlformats.org/drawingml/2006/main" xmlns:r="http://schemas.openxmlformats.org/officeDocument/2006/relationships" xmlns:p="http://schemas.openxmlformats.org/presentationml/2006/main">
+  <p:cSld>
+    <p:spTree>
+      <p:nvGrpSpPr>
+        <p:cNvPr id="1" name=""/>
+        <p:cNvGrpSpPr/>
+        <p:nvPr/>
+      </p:nvGrpSpPr>
+      <p:grpSpPr>
+        <a:xfrm>
+          <a:off x="0" y="0"/>
+          <a:ext cx="0" cy="0"/>
+          <a:chOff x="0" y="0"/>
+          <a:chExt cx="0" cy="0"/>
+        </a:xfrm>
+      </p:grpSpPr>
+      <p:pic>
+        <p:nvPicPr>
+          <p:cNvPr id="2" name="slide12.png"/>
           <p:cNvPicPr>
             <a:picLocks noChangeAspect="1"/>
           </p:cNvPicPr>
@@ -137,7 +290,7 @@
       </p:grpSpPr>
       <p:pic>
         <p:nvPicPr>
-          <p:cNvPr id="2" name="slide_02.png"/>
+          <p:cNvPr id="2" name="slide2.png"/>
           <p:cNvPicPr>
             <a:picLocks noChangeAspect="1"/>
           </p:cNvPicPr>
@@ -186,7 +339,7 @@
       </p:grpSpPr>
       <p:pic>
         <p:nvPicPr>
-          <p:cNvPr id="2" name="slide_03.png"/>
+          <p:cNvPr id="2" name="slide3.png"/>
           <p:cNvPicPr>
             <a:picLocks noChangeAspect="1"/>
           </p:cNvPicPr>
@@ -235,7 +388,7 @@
       </p:grpSpPr>
       <p:pic>
         <p:nvPicPr>
-          <p:cNvPr id="2" name="slide_04.png"/>
+          <p:cNvPr id="2" name="slide4.png"/>
           <p:cNvPicPr>
             <a:picLocks noChangeAspect="1"/>
           </p:cNvPicPr>
@@ -284,7 +437,7 @@
       </p:grpSpPr>
       <p:pic>
         <p:nvPicPr>
-          <p:cNvPr id="2" name="slide_05.png"/>
+          <p:cNvPr id="2" name="slide5.png"/>
           <p:cNvPicPr>
             <a:picLocks noChangeAspect="1"/>
           </p:cNvPicPr>
@@ -333,7 +486,154 @@
       </p:grpSpPr>
       <p:pic>
         <p:nvPicPr>
-          <p:cNvPr id="2" name="slide_06.png"/>
+          <p:cNvPr id="2" name="slide6.png"/>
+          <p:cNvPicPr>
+            <a:picLocks noChangeAspect="1"/>
+          </p:cNvPicPr>
+          <p:nvPr/>
+        </p:nvPicPr>
+        <p:blipFill>
+          <a:blip r:embed="rId1"/>
+          <a:stretch>
+            <a:fillRect/>
+          </a:stretch>
+        </p:blipFill>
+        <p:spPr>
+          <a:xfrm>
+            <a:off x="0" y="0"/>
+            <a:ext cx="12192000" cy="6858000"/>
+          </a:xfrm>
+          <a:prstGeom prst="rect">
+            <a:avLst/>
+          </a:prstGeom>
+        </p:spPr>
+      </p:pic>
+    </p:spTree>
+  </p:cSld>
+  <p:clrMapOvr>
+    <a:masterClrMapping/>
+  </p:clrMapOvr>
+</p:sld>
+</file>
+
+<file path=ppt/slides/slide7.xml><?xml version="1.0" encoding="utf-8"?>
+<p:sld xmlns:a="http://schemas.openxmlformats.org/drawingml/2006/main" xmlns:r="http://schemas.openxmlformats.org/officeDocument/2006/relationships" xmlns:p="http://schemas.openxmlformats.org/presentationml/2006/main">
+  <p:cSld>
+    <p:spTree>
+      <p:nvGrpSpPr>
+        <p:cNvPr id="1" name=""/>
+        <p:cNvGrpSpPr/>
+        <p:nvPr/>
+      </p:nvGrpSpPr>
+      <p:grpSpPr>
+        <a:xfrm>
+          <a:off x="0" y="0"/>
+          <a:ext cx="0" cy="0"/>
+          <a:chOff x="0" y="0"/>
+          <a:chExt cx="0" cy="0"/>
+        </a:xfrm>
+      </p:grpSpPr>
+      <p:pic>
+        <p:nvPicPr>
+          <p:cNvPr id="2" name="slide7.png"/>
+          <p:cNvPicPr>
+            <a:picLocks noChangeAspect="1"/>
+          </p:cNvPicPr>
+          <p:nvPr/>
+        </p:nvPicPr>
+        <p:blipFill>
+          <a:blip r:embed="rId1"/>
+          <a:stretch>
+            <a:fillRect/>
+          </a:stretch>
+        </p:blipFill>
+        <p:spPr>
+          <a:xfrm>
+            <a:off x="0" y="0"/>
+            <a:ext cx="12192000" cy="6858000"/>
+          </a:xfrm>
+          <a:prstGeom prst="rect">
+            <a:avLst/>
+          </a:prstGeom>
+        </p:spPr>
+      </p:pic>
+    </p:spTree>
+  </p:cSld>
+  <p:clrMapOvr>
+    <a:masterClrMapping/>
+  </p:clrMapOvr>
+</p:sld>
+</file>
+
+<file path=ppt/slides/slide8.xml><?xml version="1.0" encoding="utf-8"?>
+<p:sld xmlns:a="http://schemas.openxmlformats.org/drawingml/2006/main" xmlns:r="http://schemas.openxmlformats.org/officeDocument/2006/relationships" xmlns:p="http://schemas.openxmlformats.org/presentationml/2006/main">
+  <p:cSld>
+    <p:spTree>
+      <p:nvGrpSpPr>
+        <p:cNvPr id="1" name=""/>
+        <p:cNvGrpSpPr/>
+        <p:nvPr/>
+      </p:nvGrpSpPr>
+      <p:grpSpPr>
+        <a:xfrm>
+          <a:off x="0" y="0"/>
+          <a:ext cx="0" cy="0"/>
+          <a:chOff x="0" y="0"/>
+          <a:chExt cx="0" cy="0"/>
+        </a:xfrm>
+      </p:grpSpPr>
+      <p:pic>
+        <p:nvPicPr>
+          <p:cNvPr id="2" name="slide8.png"/>
+          <p:cNvPicPr>
+            <a:picLocks noChangeAspect="1"/>
+          </p:cNvPicPr>
+          <p:nvPr/>
+        </p:nvPicPr>
+        <p:blipFill>
+          <a:blip r:embed="rId1"/>
+          <a:stretch>
+            <a:fillRect/>
+          </a:stretch>
+        </p:blipFill>
+        <p:spPr>
+          <a:xfrm>
+            <a:off x="0" y="0"/>
+            <a:ext cx="12192000" cy="6858000"/>
+          </a:xfrm>
+          <a:prstGeom prst="rect">
+            <a:avLst/>
+          </a:prstGeom>
+        </p:spPr>
+      </p:pic>
+    </p:spTree>
+  </p:cSld>
+  <p:clrMapOvr>
+    <a:masterClrMapping/>
+  </p:clrMapOvr>
+</p:sld>
+</file>
+
+<file path=ppt/slides/slide9.xml><?xml version="1.0" encoding="utf-8"?>
+<p:sld xmlns:a="http://schemas.openxmlformats.org/drawingml/2006/main" xmlns:r="http://schemas.openxmlformats.org/officeDocument/2006/relationships" xmlns:p="http://schemas.openxmlformats.org/presentationml/2006/main">
+  <p:cSld>
+    <p:spTree>
+      <p:nvGrpSpPr>
+        <p:cNvPr id="1" name=""/>
+        <p:cNvGrpSpPr/>
+        <p:nvPr/>
+      </p:nvGrpSpPr>
+      <p:grpSpPr>
+        <a:xfrm>
+          <a:off x="0" y="0"/>
+          <a:ext cx="0" cy="0"/>
+          <a:chOff x="0" y="0"/>
+          <a:chExt cx="0" cy="0"/>
+        </a:xfrm>
+      </p:grpSpPr>
+      <p:pic>
+        <p:nvPicPr>
+          <p:cNvPr id="2" name="slide9.png"/>
           <p:cNvPicPr>
             <a:picLocks noChangeAspect="1"/>
           </p:cNvPicPr>
@@ -406,10 +706,10 @@
     </a:clrScheme>
     <a:fontScheme name="MAGG">
       <a:majorFont>
-        <a:latin typeface="Segoe UI"/>
+        <a:latin typeface="Microsoft YaHei"/>
       </a:majorFont>
       <a:minorFont>
-        <a:latin typeface="Segoe UI"/>
+        <a:latin typeface="Microsoft YaHei"/>
       </a:minorFont>
     </a:fontScheme>
     <a:fmtScheme name="MAGG">

</xml_diff>